<commit_message>
feat: integracion oficial de Planta Alta segun informe tecnico y plano arquitectonico (Gabinete 31 PCs, Rack 6U, Streaming, Auditorio, fotos reales y reporte 14 puntos)
</commit_message>
<xml_diff>
--- a/distribucion_aulas_editable.pptx
+++ b/distribucion_aulas_editable.pptx
@@ -14,6 +14,12 @@
     <p:sldId id="262" r:id="rId13"/>
     <p:sldId id="263" r:id="rId14"/>
     <p:sldId id="264" r:id="rId15"/>
+    <p:sldId id="265" r:id="rId16"/>
+    <p:sldId id="266" r:id="rId17"/>
+    <p:sldId id="267" r:id="rId18"/>
+    <p:sldId id="268" r:id="rId19"/>
+    <p:sldId id="269" r:id="rId20"/>
+    <p:sldId id="270" r:id="rId21"/>
   </p:sldIdLst>
   <p:sldSz cx="12191695" cy="6858000" type="screen4x3"/>
   <p:notesSz cx="6858000" cy="9144000"/>
@@ -3452,6 +3458,1806 @@
             </a:pPr>
             <a:r>
               <a:t>Ministerio de Educación  •  Dirección de Tecnología e Infraestructura Edilicia  •  Documento Técnico</a:t>
+            </a:r>
+          </a:p>
+        </p:txBody>
+      </p:sp>
+    </p:spTree>
+  </p:cSld>
+  <p:clrMapOvr>
+    <a:masterClrMapping/>
+  </p:clrMapOvr>
+</p:sld>
+</file>
+
+<file path=ppt/slides/slide10.xml><?xml version="1.0" encoding="utf-8"?>
+<p:sld xmlns:a="http://schemas.openxmlformats.org/drawingml/2006/main" xmlns:p="http://schemas.openxmlformats.org/presentationml/2006/main" xmlns:r="http://schemas.openxmlformats.org/officeDocument/2006/relationships">
+  <p:cSld>
+    <p:spTree>
+      <p:nvGrpSpPr>
+        <p:cNvPr id="1" name=""/>
+        <p:cNvGrpSpPr/>
+        <p:nvPr/>
+      </p:nvGrpSpPr>
+      <p:grpSpPr/>
+      <p:sp>
+        <p:nvSpPr>
+          <p:cNvPr id="2" name="Rectangle 1"/>
+          <p:cNvSpPr/>
+          <p:nvPr/>
+        </p:nvSpPr>
+        <p:spPr>
+          <a:xfrm>
+            <a:off x="0" y="0"/>
+            <a:ext cx="12191695" cy="6858000"/>
+          </a:xfrm>
+          <a:prstGeom prst="rect">
+            <a:avLst/>
+          </a:prstGeom>
+          <a:solidFill>
+            <a:srgbClr val="0F172A"/>
+          </a:solidFill>
+          <a:ln>
+            <a:noFill/>
+          </a:ln>
+        </p:spPr>
+        <p:style>
+          <a:lnRef idx="1">
+            <a:schemeClr val="accent1"/>
+          </a:lnRef>
+          <a:fillRef idx="3">
+            <a:schemeClr val="accent1"/>
+          </a:fillRef>
+          <a:effectRef idx="2">
+            <a:schemeClr val="accent1"/>
+          </a:effectRef>
+          <a:fontRef idx="minor">
+            <a:schemeClr val="lt1"/>
+          </a:fontRef>
+        </p:style>
+        <p:txBody>
+          <a:bodyPr rtlCol="0" anchor="ctr"/>
+          <a:lstStyle/>
+          <a:p>
+            <a:pPr algn="ctr"/>
+          </a:p>
+        </p:txBody>
+      </p:sp>
+      <p:sp>
+        <p:nvSpPr>
+          <p:cNvPr id="3" name="Rounded Rectangle 2"/>
+          <p:cNvSpPr/>
+          <p:nvPr/>
+        </p:nvSpPr>
+        <p:spPr>
+          <a:xfrm>
+            <a:off x="914400" y="731520"/>
+            <a:ext cx="10362895" cy="5394960"/>
+          </a:xfrm>
+          <a:prstGeom prst="roundRect">
+            <a:avLst/>
+          </a:prstGeom>
+          <a:solidFill>
+            <a:srgbClr val="1E293B"/>
+          </a:solidFill>
+          <a:ln w="25400">
+            <a:solidFill>
+              <a:srgbClr val="0EA5E9"/>
+            </a:solidFill>
+          </a:ln>
+        </p:spPr>
+        <p:style>
+          <a:lnRef idx="1">
+            <a:schemeClr val="accent1"/>
+          </a:lnRef>
+          <a:fillRef idx="3">
+            <a:schemeClr val="accent1"/>
+          </a:fillRef>
+          <a:effectRef idx="2">
+            <a:schemeClr val="accent1"/>
+          </a:effectRef>
+          <a:fontRef idx="minor">
+            <a:schemeClr val="lt1"/>
+          </a:fontRef>
+        </p:style>
+        <p:txBody>
+          <a:bodyPr rtlCol="0" anchor="ctr" wrap="square" lIns="548640" rIns="548640" tIns="548640"/>
+          <a:lstStyle/>
+          <a:p>
+            <a:pPr algn="ctr">
+              <a:defRPr sz="2800" b="1">
+                <a:solidFill>
+                  <a:srgbClr val="FFFFFF"/>
+                </a:solidFill>
+                <a:latin typeface="Segoe UI"/>
+              </a:defRPr>
+            </a:pPr>
+            <a:r>
+              <a:t>INFORME GENERAL • PLANTA ALTA</a:t>
+            </a:r>
+          </a:p>
+          <a:p>
+            <a:pPr algn="ctr">
+              <a:defRPr sz="1800" b="1">
+                <a:solidFill>
+                  <a:srgbClr val="0EA5E9"/>
+                </a:solidFill>
+                <a:latin typeface="Segoe UI"/>
+              </a:defRPr>
+            </a:pPr>
+            <a:r>
+              <a:t>INSTITUTO DE EDUCACIÓN SUPERIOR "NUEVO HORIZONTE"</a:t>
+            </a:r>
+          </a:p>
+          <a:p>
+            <a:pPr algn="ctr">
+              <a:defRPr sz="1300">
+                <a:solidFill>
+                  <a:srgbClr val="CBD5E1"/>
+                </a:solidFill>
+                <a:latin typeface="Segoe UI"/>
+              </a:defRPr>
+            </a:pPr>
+            <a:r>
+              <a:t>Relevamiento Arquitectónico, Infraestructura Tecnológica &amp; Red de Datos</a:t>
+            </a:r>
+          </a:p>
+        </p:txBody>
+      </p:sp>
+      <p:sp>
+        <p:nvSpPr>
+          <p:cNvPr id="4" name="Rectangle 3"/>
+          <p:cNvSpPr/>
+          <p:nvPr/>
+        </p:nvSpPr>
+        <p:spPr>
+          <a:xfrm>
+            <a:off x="1463040" y="2926080"/>
+            <a:ext cx="9265615" cy="2743200"/>
+          </a:xfrm>
+          <a:prstGeom prst="rect">
+            <a:avLst/>
+          </a:prstGeom>
+          <a:solidFill>
+            <a:srgbClr val="0F172A"/>
+          </a:solidFill>
+          <a:ln>
+            <a:solidFill>
+              <a:srgbClr val="334155"/>
+            </a:solidFill>
+          </a:ln>
+        </p:spPr>
+        <p:style>
+          <a:lnRef idx="1">
+            <a:schemeClr val="accent1"/>
+          </a:lnRef>
+          <a:fillRef idx="3">
+            <a:schemeClr val="accent1"/>
+          </a:fillRef>
+          <a:effectRef idx="2">
+            <a:schemeClr val="accent1"/>
+          </a:effectRef>
+          <a:fontRef idx="minor">
+            <a:schemeClr val="lt1"/>
+          </a:fontRef>
+        </p:style>
+        <p:txBody>
+          <a:bodyPr rtlCol="0" anchor="ctr" lIns="365760" tIns="274320"/>
+          <a:lstStyle/>
+          <a:p>
+            <a:pPr algn="ctr"/>
+          </a:p>
+          <a:p>
+            <a:pPr>
+              <a:defRPr sz="1100" b="1">
+                <a:solidFill>
+                  <a:srgbClr val="0EA5E9"/>
+                </a:solidFill>
+                <a:latin typeface="Segoe UI"/>
+              </a:defRPr>
+            </a:pPr>
+            <a:r>
+              <a:t>UBICACIÓN: </a:t>
+            </a:r>
+            <a:r>
+              <a:rPr b="0">
+                <a:solidFill>
+                  <a:srgbClr val="FFFFFF"/>
+                </a:solidFill>
+              </a:rPr>
+              <a:t>Manuel Castellano 3323 esq. Ildefonso M. de la Paz, B° 47 Hectáreas, Alto Comedero, San Salvador de Jujuy</a:t>
+            </a:r>
+          </a:p>
+          <a:p>
+            <a:pPr>
+              <a:defRPr sz="1100" b="1">
+                <a:solidFill>
+                  <a:srgbClr val="0EA5E9"/>
+                </a:solidFill>
+                <a:latin typeface="Segoe UI"/>
+              </a:defRPr>
+            </a:pPr>
+            <a:r>
+              <a:t>CARRERA: </a:t>
+            </a:r>
+            <a:r>
+              <a:rPr b="0">
+                <a:solidFill>
+                  <a:srgbClr val="FFFFFF"/>
+                </a:solidFill>
+              </a:rPr>
+              <a:t>Tecnicatura Superior en Desarrollo de Software</a:t>
+            </a:r>
+          </a:p>
+          <a:p>
+            <a:pPr>
+              <a:defRPr sz="1100" b="1">
+                <a:solidFill>
+                  <a:srgbClr val="0EA5E9"/>
+                </a:solidFill>
+                <a:latin typeface="Segoe UI"/>
+              </a:defRPr>
+            </a:pPr>
+            <a:r>
+              <a:t>CURSO &amp; DIVISIÓN: </a:t>
+            </a:r>
+            <a:r>
+              <a:rPr b="0">
+                <a:solidFill>
+                  <a:srgbClr val="FFFFFF"/>
+                </a:solidFill>
+              </a:rPr>
+              <a:t>3º Año - 1ª División</a:t>
+            </a:r>
+          </a:p>
+          <a:p>
+            <a:pPr>
+              <a:defRPr sz="1100" b="1">
+                <a:solidFill>
+                  <a:srgbClr val="0EA5E9"/>
+                </a:solidFill>
+                <a:latin typeface="Segoe UI"/>
+              </a:defRPr>
+            </a:pPr>
+            <a:r>
+              <a:t>TURNO: </a:t>
+            </a:r>
+            <a:r>
+              <a:rPr b="0">
+                <a:solidFill>
+                  <a:srgbClr val="FFFFFF"/>
+                </a:solidFill>
+              </a:rPr>
+              <a:t>Turno Tarde</a:t>
+            </a:r>
+          </a:p>
+          <a:p>
+            <a:pPr>
+              <a:defRPr sz="1100" b="1">
+                <a:solidFill>
+                  <a:srgbClr val="0EA5E9"/>
+                </a:solidFill>
+                <a:latin typeface="Segoe UI"/>
+              </a:defRPr>
+            </a:pPr>
+            <a:r>
+              <a:t>AÑO LECTIVO: </a:t>
+            </a:r>
+            <a:r>
+              <a:rPr b="0">
+                <a:solidFill>
+                  <a:srgbClr val="FFFFFF"/>
+                </a:solidFill>
+              </a:rPr>
+              <a:t>2026</a:t>
+            </a:r>
+          </a:p>
+          <a:p>
+            <a:pPr>
+              <a:defRPr sz="1100" b="1">
+                <a:solidFill>
+                  <a:srgbClr val="0EA5E9"/>
+                </a:solidFill>
+                <a:latin typeface="Segoe UI"/>
+              </a:defRPr>
+            </a:pPr>
+            <a:r>
+              <a:t>ESPACIOS AUDITADOS: </a:t>
+            </a:r>
+            <a:r>
+              <a:rPr b="0">
+                <a:solidFill>
+                  <a:srgbClr val="FFFFFF"/>
+                </a:solidFill>
+              </a:rPr>
+              <a:t>Gabinete (31 PCs), Aula, Sector Títulos, Sala de Streaming, Sala Previa, Auditorio, Baños y Rack 6U</a:t>
+            </a:r>
+          </a:p>
+        </p:txBody>
+      </p:sp>
+      <p:pic>
+        <p:nvPicPr>
+          <p:cNvPr id="5" name="Picture 4" descr="logo_institucional.jpeg"/>
+          <p:cNvPicPr>
+            <a:picLocks noChangeAspect="1"/>
+          </p:cNvPicPr>
+          <p:nvPr/>
+        </p:nvPicPr>
+        <p:blipFill>
+          <a:blip r:embed="rId2"/>
+          <a:stretch>
+            <a:fillRect/>
+          </a:stretch>
+        </p:blipFill>
+        <p:spPr>
+          <a:xfrm>
+            <a:off x="9631375" y="1005840"/>
+            <a:ext cx="1280160" cy="2275840"/>
+          </a:xfrm>
+          <a:prstGeom prst="rect">
+            <a:avLst/>
+          </a:prstGeom>
+        </p:spPr>
+      </p:pic>
+    </p:spTree>
+  </p:cSld>
+  <p:clrMapOvr>
+    <a:masterClrMapping/>
+  </p:clrMapOvr>
+</p:sld>
+</file>
+
+<file path=ppt/slides/slide11.xml><?xml version="1.0" encoding="utf-8"?>
+<p:sld xmlns:a="http://schemas.openxmlformats.org/drawingml/2006/main" xmlns:p="http://schemas.openxmlformats.org/presentationml/2006/main" xmlns:r="http://schemas.openxmlformats.org/officeDocument/2006/relationships">
+  <p:cSld>
+    <p:spTree>
+      <p:nvGrpSpPr>
+        <p:cNvPr id="1" name=""/>
+        <p:cNvGrpSpPr/>
+        <p:nvPr/>
+      </p:nvGrpSpPr>
+      <p:grpSpPr/>
+      <p:sp>
+        <p:nvSpPr>
+          <p:cNvPr id="2" name="Rectangle 1"/>
+          <p:cNvSpPr/>
+          <p:nvPr/>
+        </p:nvSpPr>
+        <p:spPr>
+          <a:xfrm>
+            <a:off x="0" y="0"/>
+            <a:ext cx="12191695" cy="1005840"/>
+          </a:xfrm>
+          <a:prstGeom prst="rect">
+            <a:avLst/>
+          </a:prstGeom>
+          <a:solidFill>
+            <a:srgbClr val="0F172A"/>
+          </a:solidFill>
+          <a:ln w="25400">
+            <a:solidFill>
+              <a:srgbClr val="2563EB"/>
+            </a:solidFill>
+          </a:ln>
+        </p:spPr>
+        <p:style>
+          <a:lnRef idx="1">
+            <a:schemeClr val="accent1"/>
+          </a:lnRef>
+          <a:fillRef idx="3">
+            <a:schemeClr val="accent1"/>
+          </a:fillRef>
+          <a:effectRef idx="2">
+            <a:schemeClr val="accent1"/>
+          </a:effectRef>
+          <a:fontRef idx="minor">
+            <a:schemeClr val="lt1"/>
+          </a:fontRef>
+        </p:style>
+        <p:txBody>
+          <a:bodyPr rtlCol="0" anchor="ctr" wrap="square" lIns="457200" tIns="137160"/>
+          <a:lstStyle/>
+          <a:p>
+            <a:pPr algn="ctr">
+              <a:defRPr sz="2000" b="1">
+                <a:solidFill>
+                  <a:srgbClr val="FFFFFF"/>
+                </a:solidFill>
+                <a:latin typeface="Segoe UI"/>
+              </a:defRPr>
+            </a:pPr>
+            <a:r>
+              <a:t>PLANTA ALTA  •  Plano Arquitectónico y Distribución Espacial</a:t>
+            </a:r>
+          </a:p>
+          <a:p>
+            <a:pPr>
+              <a:defRPr sz="1100">
+                <a:solidFill>
+                  <a:srgbClr val="0EA5E9"/>
+                </a:solidFill>
+                <a:latin typeface="Segoe UI"/>
+              </a:defRPr>
+            </a:pPr>
+            <a:r>
+              <a:t>Organización de formación, gestión académica, producción técnica y eventos (Anexo Oficial IESNH)</a:t>
+            </a:r>
+          </a:p>
+        </p:txBody>
+      </p:sp>
+      <p:pic>
+        <p:nvPicPr>
+          <p:cNvPr id="3" name="Picture 2" descr="plano_planta_alta_original.png"/>
+          <p:cNvPicPr>
+            <a:picLocks noChangeAspect="1"/>
+          </p:cNvPicPr>
+          <p:nvPr/>
+        </p:nvPicPr>
+        <p:blipFill>
+          <a:blip r:embed="rId2"/>
+          <a:stretch>
+            <a:fillRect/>
+          </a:stretch>
+        </p:blipFill>
+        <p:spPr>
+          <a:xfrm>
+            <a:off x="457200" y="1188720"/>
+            <a:ext cx="7498079" cy="4652093"/>
+          </a:xfrm>
+          <a:prstGeom prst="rect">
+            <a:avLst/>
+          </a:prstGeom>
+        </p:spPr>
+      </p:pic>
+      <p:sp>
+        <p:nvSpPr>
+          <p:cNvPr id="4" name="Rounded Rectangle 3"/>
+          <p:cNvSpPr/>
+          <p:nvPr/>
+        </p:nvSpPr>
+        <p:spPr>
+          <a:xfrm>
+            <a:off x="8138160" y="1188720"/>
+            <a:ext cx="3657600" cy="5303520"/>
+          </a:xfrm>
+          <a:prstGeom prst="roundRect">
+            <a:avLst/>
+          </a:prstGeom>
+          <a:solidFill>
+            <a:srgbClr val="0F172A"/>
+          </a:solidFill>
+          <a:ln>
+            <a:solidFill>
+              <a:srgbClr val="2563EB"/>
+            </a:solidFill>
+          </a:ln>
+        </p:spPr>
+        <p:style>
+          <a:lnRef idx="1">
+            <a:schemeClr val="accent1"/>
+          </a:lnRef>
+          <a:fillRef idx="3">
+            <a:schemeClr val="accent1"/>
+          </a:fillRef>
+          <a:effectRef idx="2">
+            <a:schemeClr val="accent1"/>
+          </a:effectRef>
+          <a:fontRef idx="minor">
+            <a:schemeClr val="lt1"/>
+          </a:fontRef>
+        </p:style>
+        <p:txBody>
+          <a:bodyPr rtlCol="0" anchor="ctr" lIns="228600" rIns="228600" tIns="228600"/>
+          <a:lstStyle/>
+          <a:p>
+            <a:pPr algn="ctr">
+              <a:defRPr sz="1400" b="1">
+                <a:solidFill>
+                  <a:srgbClr val="FFFFFF"/>
+                </a:solidFill>
+                <a:latin typeface="Segoe UI"/>
+              </a:defRPr>
+            </a:pPr>
+            <a:r>
+              <a:t>Sectores de Planta Alta</a:t>
+            </a:r>
+          </a:p>
+          <a:p>
+            <a:pPr>
+              <a:defRPr sz="950" b="1">
+                <a:solidFill>
+                  <a:srgbClr val="0EA5E9"/>
+                </a:solidFill>
+                <a:latin typeface="Segoe UI"/>
+              </a:defRPr>
+            </a:pPr>
+            <a:r>
+              <a:t>• Gabinete Informático: </a:t>
+            </a:r>
+            <a:r>
+              <a:rPr b="0">
+                <a:solidFill>
+                  <a:srgbClr val="E2E8F0"/>
+                </a:solidFill>
+              </a:rPr>
+              <a:t>31 PCs en 4 islas dobles, Rack pivotante 6U y Deco 1.</a:t>
+            </a:r>
+          </a:p>
+          <a:p>
+            <a:pPr>
+              <a:defRPr sz="950" b="1">
+                <a:solidFill>
+                  <a:srgbClr val="0EA5E9"/>
+                </a:solidFill>
+                <a:latin typeface="Segoe UI"/>
+              </a:defRPr>
+            </a:pPr>
+            <a:r>
+              <a:t>• Aula: </a:t>
+            </a:r>
+            <a:r>
+              <a:rPr b="0">
+                <a:solidFill>
+                  <a:srgbClr val="E2E8F0"/>
+                </a:solidFill>
+              </a:rPr>
+              <a:t>Capacitaciones y clases académicas con conectividad.</a:t>
+            </a:r>
+          </a:p>
+          <a:p>
+            <a:pPr>
+              <a:defRPr sz="950" b="1">
+                <a:solidFill>
+                  <a:srgbClr val="0EA5E9"/>
+                </a:solidFill>
+                <a:latin typeface="Segoe UI"/>
+              </a:defRPr>
+            </a:pPr>
+            <a:r>
+              <a:t>• Sector Títulos: </a:t>
+            </a:r>
+            <a:r>
+              <a:rPr b="0">
+                <a:solidFill>
+                  <a:srgbClr val="E2E8F0"/>
+                </a:solidFill>
+              </a:rPr>
+              <a:t>Mesa ejecutiva de resguardo y entrega de títulos/certificados.</a:t>
+            </a:r>
+          </a:p>
+          <a:p>
+            <a:pPr>
+              <a:defRPr sz="950" b="1">
+                <a:solidFill>
+                  <a:srgbClr val="0EA5E9"/>
+                </a:solidFill>
+                <a:latin typeface="Segoe UI"/>
+              </a:defRPr>
+            </a:pPr>
+            <a:r>
+              <a:t>• Sala de Streaming: </a:t>
+            </a:r>
+            <a:r>
+              <a:rPr b="0">
+                <a:solidFill>
+                  <a:srgbClr val="E2E8F0"/>
+                </a:solidFill>
+              </a:rPr>
+              <a:t>Producción audiovisual, mesa de 4 conductores y 3 PCs técnicas.</a:t>
+            </a:r>
+          </a:p>
+          <a:p>
+            <a:pPr>
+              <a:defRPr sz="950" b="1">
+                <a:solidFill>
+                  <a:srgbClr val="0EA5E9"/>
+                </a:solidFill>
+                <a:latin typeface="Segoe UI"/>
+              </a:defRPr>
+            </a:pPr>
+            <a:r>
+              <a:t>• Escalera Principal: </a:t>
+            </a:r>
+            <a:r>
+              <a:rPr b="0">
+                <a:solidFill>
+                  <a:srgbClr val="E2E8F0"/>
+                </a:solidFill>
+              </a:rPr>
+              <a:t>Núcleo de circulación vertical conectado a Planta Baja.</a:t>
+            </a:r>
+          </a:p>
+          <a:p>
+            <a:pPr>
+              <a:defRPr sz="950" b="1">
+                <a:solidFill>
+                  <a:srgbClr val="0EA5E9"/>
+                </a:solidFill>
+                <a:latin typeface="Segoe UI"/>
+              </a:defRPr>
+            </a:pPr>
+            <a:r>
+              <a:t>• Baños Diferenciados: </a:t>
+            </a:r>
+            <a:r>
+              <a:rPr b="0">
+                <a:solidFill>
+                  <a:srgbClr val="E2E8F0"/>
+                </a:solidFill>
+              </a:rPr>
+              <a:t>Caballeros y Damas en zona central con Deco n2.</a:t>
+            </a:r>
+          </a:p>
+          <a:p>
+            <a:pPr>
+              <a:defRPr sz="950" b="1">
+                <a:solidFill>
+                  <a:srgbClr val="0EA5E9"/>
+                </a:solidFill>
+                <a:latin typeface="Segoe UI"/>
+              </a:defRPr>
+            </a:pPr>
+            <a:r>
+              <a:t>• Sala Previa: </a:t>
+            </a:r>
+            <a:r>
+              <a:rPr b="0">
+                <a:solidFill>
+                  <a:srgbClr val="E2E8F0"/>
+                </a:solidFill>
+              </a:rPr>
+              <a:t>Recepción antes del auditorio, mesa de reuniones y sillones.</a:t>
+            </a:r>
+          </a:p>
+          <a:p>
+            <a:pPr>
+              <a:defRPr sz="950" b="1">
+                <a:solidFill>
+                  <a:srgbClr val="0EA5E9"/>
+                </a:solidFill>
+                <a:latin typeface="Segoe UI"/>
+              </a:defRPr>
+            </a:pPr>
+            <a:r>
+              <a:t>• Auditorio Institucional: </a:t>
+            </a:r>
+            <a:r>
+              <a:rPr b="0">
+                <a:solidFill>
+                  <a:srgbClr val="E2E8F0"/>
+                </a:solidFill>
+              </a:rPr>
+              <a:t>Gran capacidad, estrado superior, Deco n3 y 64-100 butacas.</a:t>
+            </a:r>
+          </a:p>
+        </p:txBody>
+      </p:sp>
+    </p:spTree>
+  </p:cSld>
+  <p:clrMapOvr>
+    <a:masterClrMapping/>
+  </p:clrMapOvr>
+</p:sld>
+</file>
+
+<file path=ppt/slides/slide12.xml><?xml version="1.0" encoding="utf-8"?>
+<p:sld xmlns:a="http://schemas.openxmlformats.org/drawingml/2006/main" xmlns:p="http://schemas.openxmlformats.org/presentationml/2006/main" xmlns:r="http://schemas.openxmlformats.org/officeDocument/2006/relationships">
+  <p:cSld>
+    <p:spTree>
+      <p:nvGrpSpPr>
+        <p:cNvPr id="1" name=""/>
+        <p:cNvGrpSpPr/>
+        <p:nvPr/>
+      </p:nvGrpSpPr>
+      <p:grpSpPr/>
+      <p:sp>
+        <p:nvSpPr>
+          <p:cNvPr id="2" name="Rectangle 1"/>
+          <p:cNvSpPr/>
+          <p:nvPr/>
+        </p:nvSpPr>
+        <p:spPr>
+          <a:xfrm>
+            <a:off x="0" y="0"/>
+            <a:ext cx="12191695" cy="1005840"/>
+          </a:xfrm>
+          <a:prstGeom prst="rect">
+            <a:avLst/>
+          </a:prstGeom>
+          <a:solidFill>
+            <a:srgbClr val="0F172A"/>
+          </a:solidFill>
+          <a:ln w="25400">
+            <a:solidFill>
+              <a:srgbClr val="2563EB"/>
+            </a:solidFill>
+          </a:ln>
+        </p:spPr>
+        <p:style>
+          <a:lnRef idx="1">
+            <a:schemeClr val="accent1"/>
+          </a:lnRef>
+          <a:fillRef idx="3">
+            <a:schemeClr val="accent1"/>
+          </a:fillRef>
+          <a:effectRef idx="2">
+            <a:schemeClr val="accent1"/>
+          </a:effectRef>
+          <a:fontRef idx="minor">
+            <a:schemeClr val="lt1"/>
+          </a:fontRef>
+        </p:style>
+        <p:txBody>
+          <a:bodyPr rtlCol="0" anchor="ctr" wrap="square" lIns="457200" tIns="137160"/>
+          <a:lstStyle/>
+          <a:p>
+            <a:pPr algn="ctr">
+              <a:defRPr sz="2000" b="1">
+                <a:solidFill>
+                  <a:srgbClr val="FFFFFF"/>
+                </a:solidFill>
+                <a:latin typeface="Segoe UI"/>
+              </a:defRPr>
+            </a:pPr>
+            <a:r>
+              <a:t>GABINETE INFORMÁTICO &amp; RACK DE COMUNICACIONES</a:t>
+            </a:r>
+          </a:p>
+          <a:p>
+            <a:pPr>
+              <a:defRPr sz="1100">
+                <a:solidFill>
+                  <a:srgbClr val="0EA5E9"/>
+                </a:solidFill>
+                <a:latin typeface="Segoe UI"/>
+              </a:defRPr>
+            </a:pPr>
+            <a:r>
+              <a:t>31 computadoras operativas, cableado estructurado y Rack Mural SOHO 6U pivotante</a:t>
+            </a:r>
+          </a:p>
+        </p:txBody>
+      </p:sp>
+      <p:sp>
+        <p:nvSpPr>
+          <p:cNvPr id="3" name="Rounded Rectangle 2"/>
+          <p:cNvSpPr/>
+          <p:nvPr/>
+        </p:nvSpPr>
+        <p:spPr>
+          <a:xfrm>
+            <a:off x="457200" y="1188720"/>
+            <a:ext cx="5486400" cy="5303520"/>
+          </a:xfrm>
+          <a:prstGeom prst="roundRect">
+            <a:avLst/>
+          </a:prstGeom>
+          <a:solidFill>
+            <a:srgbClr val="FFFFFF"/>
+          </a:solidFill>
+          <a:ln>
+            <a:solidFill>
+              <a:srgbClr val="CBD5E1"/>
+            </a:solidFill>
+          </a:ln>
+        </p:spPr>
+        <p:style>
+          <a:lnRef idx="1">
+            <a:schemeClr val="accent1"/>
+          </a:lnRef>
+          <a:fillRef idx="3">
+            <a:schemeClr val="accent1"/>
+          </a:fillRef>
+          <a:effectRef idx="2">
+            <a:schemeClr val="accent1"/>
+          </a:effectRef>
+          <a:fontRef idx="minor">
+            <a:schemeClr val="lt1"/>
+          </a:fontRef>
+        </p:style>
+        <p:txBody>
+          <a:bodyPr rtlCol="0" anchor="ctr" lIns="274320" tIns="182880"/>
+          <a:lstStyle/>
+          <a:p>
+            <a:pPr algn="ctr">
+              <a:defRPr sz="1300" b="1">
+                <a:solidFill>
+                  <a:srgbClr val="0F172A"/>
+                </a:solidFill>
+                <a:latin typeface="Segoe UI"/>
+              </a:defRPr>
+            </a:pPr>
+            <a:r>
+              <a:t>Aula Informática / Gabinete (31 Computadoras)</a:t>
+            </a:r>
+          </a:p>
+          <a:p>
+            <a:pPr>
+              <a:defRPr sz="1000">
+                <a:solidFill>
+                  <a:srgbClr val="0F172A"/>
+                </a:solidFill>
+                <a:latin typeface="Segoe UI"/>
+              </a:defRPr>
+            </a:pPr>
+            <a:r>
+              <a:t>Equipado con 31 computadoras distribuidas en 4 filas de puestos dobles para estudiantes y docentes. Permite desarrollar clases prácticas, evaluaciones y actividades que requieren recursos digitales e Internet.</a:t>
+            </a:r>
+          </a:p>
+        </p:txBody>
+      </p:sp>
+      <p:pic>
+        <p:nvPicPr>
+          <p:cNvPr id="4" name="Picture 3" descr="foto_gabinete_31pcs.jpeg"/>
+          <p:cNvPicPr>
+            <a:picLocks noChangeAspect="1"/>
+          </p:cNvPicPr>
+          <p:nvPr/>
+        </p:nvPicPr>
+        <p:blipFill>
+          <a:blip r:embed="rId2"/>
+          <a:stretch>
+            <a:fillRect/>
+          </a:stretch>
+        </p:blipFill>
+        <p:spPr>
+          <a:xfrm>
+            <a:off x="731520" y="2743200"/>
+            <a:ext cx="4937760" cy="2776540"/>
+          </a:xfrm>
+          <a:prstGeom prst="rect">
+            <a:avLst/>
+          </a:prstGeom>
+        </p:spPr>
+      </p:pic>
+      <p:sp>
+        <p:nvSpPr>
+          <p:cNvPr id="5" name="Rounded Rectangle 4"/>
+          <p:cNvSpPr/>
+          <p:nvPr/>
+        </p:nvSpPr>
+        <p:spPr>
+          <a:xfrm>
+            <a:off x="6217920" y="1188720"/>
+            <a:ext cx="5486400" cy="5303520"/>
+          </a:xfrm>
+          <a:prstGeom prst="roundRect">
+            <a:avLst/>
+          </a:prstGeom>
+          <a:solidFill>
+            <a:srgbClr val="0F172A"/>
+          </a:solidFill>
+          <a:ln>
+            <a:solidFill>
+              <a:srgbClr val="0EA5E9"/>
+            </a:solidFill>
+          </a:ln>
+        </p:spPr>
+        <p:style>
+          <a:lnRef idx="1">
+            <a:schemeClr val="accent1"/>
+          </a:lnRef>
+          <a:fillRef idx="3">
+            <a:schemeClr val="accent1"/>
+          </a:fillRef>
+          <a:effectRef idx="2">
+            <a:schemeClr val="accent1"/>
+          </a:effectRef>
+          <a:fontRef idx="minor">
+            <a:schemeClr val="lt1"/>
+          </a:fontRef>
+        </p:style>
+        <p:txBody>
+          <a:bodyPr rtlCol="0" anchor="ctr" lIns="274320" tIns="182880"/>
+          <a:lstStyle/>
+          <a:p>
+            <a:pPr algn="ctr">
+              <a:defRPr sz="1300" b="1">
+                <a:solidFill>
+                  <a:srgbClr val="FFFFFF"/>
+                </a:solidFill>
+                <a:latin typeface="Segoe UI"/>
+              </a:defRPr>
+            </a:pPr>
+            <a:r>
+              <a:t>Rack Mural SOHO Pivotante (6U - 19")</a:t>
+            </a:r>
+          </a:p>
+          <a:p>
+            <a:pPr>
+              <a:defRPr sz="1000">
+                <a:solidFill>
+                  <a:srgbClr val="E2E8F0"/>
+                </a:solidFill>
+                <a:latin typeface="Segoe UI"/>
+              </a:defRPr>
+            </a:pPr>
+            <a:r>
+              <a:t>• Modelo mural pivotante de 6U con 600 mm de profundidad.</a:t>
+            </a:r>
+            <a:br/>
+            <a:r>
+              <a:t>• Módem Huawei OptiXstar HG8145X6-10.</a:t>
+            </a:r>
+            <a:br/>
+            <a:r>
+              <a:t>• 2 Switches Hikvision administrables de 24 puertos (48 bocas totales).</a:t>
+            </a:r>
+            <a:br/>
+            <a:r>
+              <a:t>• Distribución directa a las 4 islas del gabinete, Streaming y Títulos.</a:t>
+            </a:r>
+          </a:p>
+        </p:txBody>
+      </p:sp>
+      <p:pic>
+        <p:nvPicPr>
+          <p:cNvPr id="6" name="Picture 5" descr="foto_rack_comunicaciones_6u.jpeg"/>
+          <p:cNvPicPr>
+            <a:picLocks noChangeAspect="1"/>
+          </p:cNvPicPr>
+          <p:nvPr/>
+        </p:nvPicPr>
+        <p:blipFill>
+          <a:blip r:embed="rId3"/>
+          <a:stretch>
+            <a:fillRect/>
+          </a:stretch>
+        </p:blipFill>
+        <p:spPr>
+          <a:xfrm>
+            <a:off x="6858000" y="2926080"/>
+            <a:ext cx="4206240" cy="2999532"/>
+          </a:xfrm>
+          <a:prstGeom prst="rect">
+            <a:avLst/>
+          </a:prstGeom>
+        </p:spPr>
+      </p:pic>
+    </p:spTree>
+  </p:cSld>
+  <p:clrMapOvr>
+    <a:masterClrMapping/>
+  </p:clrMapOvr>
+</p:sld>
+</file>
+
+<file path=ppt/slides/slide13.xml><?xml version="1.0" encoding="utf-8"?>
+<p:sld xmlns:a="http://schemas.openxmlformats.org/drawingml/2006/main" xmlns:p="http://schemas.openxmlformats.org/presentationml/2006/main" xmlns:r="http://schemas.openxmlformats.org/officeDocument/2006/relationships">
+  <p:cSld>
+    <p:spTree>
+      <p:nvGrpSpPr>
+        <p:cNvPr id="1" name=""/>
+        <p:cNvGrpSpPr/>
+        <p:nvPr/>
+      </p:nvGrpSpPr>
+      <p:grpSpPr/>
+      <p:sp>
+        <p:nvSpPr>
+          <p:cNvPr id="2" name="Rectangle 1"/>
+          <p:cNvSpPr/>
+          <p:nvPr/>
+        </p:nvSpPr>
+        <p:spPr>
+          <a:xfrm>
+            <a:off x="0" y="0"/>
+            <a:ext cx="12191695" cy="1005840"/>
+          </a:xfrm>
+          <a:prstGeom prst="rect">
+            <a:avLst/>
+          </a:prstGeom>
+          <a:solidFill>
+            <a:srgbClr val="0F172A"/>
+          </a:solidFill>
+          <a:ln w="25400">
+            <a:solidFill>
+              <a:srgbClr val="2563EB"/>
+            </a:solidFill>
+          </a:ln>
+        </p:spPr>
+        <p:style>
+          <a:lnRef idx="1">
+            <a:schemeClr val="accent1"/>
+          </a:lnRef>
+          <a:fillRef idx="3">
+            <a:schemeClr val="accent1"/>
+          </a:fillRef>
+          <a:effectRef idx="2">
+            <a:schemeClr val="accent1"/>
+          </a:effectRef>
+          <a:fontRef idx="minor">
+            <a:schemeClr val="lt1"/>
+          </a:fontRef>
+        </p:style>
+        <p:txBody>
+          <a:bodyPr rtlCol="0" anchor="ctr" wrap="square" lIns="457200" tIns="137160"/>
+          <a:lstStyle/>
+          <a:p>
+            <a:pPr algn="ctr">
+              <a:defRPr sz="2000" b="1">
+                <a:solidFill>
+                  <a:srgbClr val="FFFFFF"/>
+                </a:solidFill>
+                <a:latin typeface="Segoe UI"/>
+              </a:defRPr>
+            </a:pPr>
+            <a:r>
+              <a:t>AUDITORIO INSTITUCIONAL &amp; SALA PREVIA</a:t>
+            </a:r>
+          </a:p>
+          <a:p>
+            <a:pPr>
+              <a:defRPr sz="1100">
+                <a:solidFill>
+                  <a:srgbClr val="0EA5E9"/>
+                </a:solidFill>
+                <a:latin typeface="Segoe UI"/>
+              </a:defRPr>
+            </a:pPr>
+            <a:r>
+              <a:t>Espacio principal de conferencias y actos protocolares con sala de recepción ejecutiva</a:t>
+            </a:r>
+          </a:p>
+        </p:txBody>
+      </p:sp>
+      <p:sp>
+        <p:nvSpPr>
+          <p:cNvPr id="3" name="Rounded Rectangle 2"/>
+          <p:cNvSpPr/>
+          <p:nvPr/>
+        </p:nvSpPr>
+        <p:spPr>
+          <a:xfrm>
+            <a:off x="457200" y="1188720"/>
+            <a:ext cx="6949440" cy="5303520"/>
+          </a:xfrm>
+          <a:prstGeom prst="roundRect">
+            <a:avLst/>
+          </a:prstGeom>
+          <a:solidFill>
+            <a:srgbClr val="FFFFFF"/>
+          </a:solidFill>
+          <a:ln>
+            <a:solidFill>
+              <a:srgbClr val="CBD5E1"/>
+            </a:solidFill>
+          </a:ln>
+        </p:spPr>
+        <p:style>
+          <a:lnRef idx="1">
+            <a:schemeClr val="accent1"/>
+          </a:lnRef>
+          <a:fillRef idx="3">
+            <a:schemeClr val="accent1"/>
+          </a:fillRef>
+          <a:effectRef idx="2">
+            <a:schemeClr val="accent1"/>
+          </a:effectRef>
+          <a:fontRef idx="minor">
+            <a:schemeClr val="lt1"/>
+          </a:fontRef>
+        </p:style>
+        <p:txBody>
+          <a:bodyPr rtlCol="0" anchor="ctr" lIns="274320" tIns="182880"/>
+          <a:lstStyle/>
+          <a:p>
+            <a:pPr algn="ctr">
+              <a:defRPr sz="1300" b="1">
+                <a:solidFill>
+                  <a:srgbClr val="0F172A"/>
+                </a:solidFill>
+                <a:latin typeface="Segoe UI"/>
+              </a:defRPr>
+            </a:pPr>
+            <a:r>
+              <a:t>Auditorio Institucional (19,5 m × 13,65 m • Altura 3,95 m)</a:t>
+            </a:r>
+          </a:p>
+          <a:p>
+            <a:pPr>
+              <a:defRPr sz="1000">
+                <a:solidFill>
+                  <a:srgbClr val="0F172A"/>
+                </a:solidFill>
+                <a:latin typeface="Segoe UI"/>
+              </a:defRPr>
+            </a:pPr>
+            <a:r>
+              <a:t>Espacio de mayor convocatoria para conferencias, exposiciones, capacitaciones y proyecciones. Disposición en 2 bloques de butacas con pasillo central hacia el estrado y punto Wi-Fi Deco n3.</a:t>
+            </a:r>
+          </a:p>
+        </p:txBody>
+      </p:sp>
+      <p:pic>
+        <p:nvPicPr>
+          <p:cNvPr id="4" name="Picture 3" descr="foto_auditorio_1.jpeg"/>
+          <p:cNvPicPr>
+            <a:picLocks noChangeAspect="1"/>
+          </p:cNvPicPr>
+          <p:nvPr/>
+        </p:nvPicPr>
+        <p:blipFill>
+          <a:blip r:embed="rId2"/>
+          <a:stretch>
+            <a:fillRect/>
+          </a:stretch>
+        </p:blipFill>
+        <p:spPr>
+          <a:xfrm>
+            <a:off x="731520" y="2651760"/>
+            <a:ext cx="3108960" cy="1750077"/>
+          </a:xfrm>
+          <a:prstGeom prst="rect">
+            <a:avLst/>
+          </a:prstGeom>
+        </p:spPr>
+      </p:pic>
+      <p:pic>
+        <p:nvPicPr>
+          <p:cNvPr id="5" name="Picture 4" descr="foto_auditorio_2.jpeg"/>
+          <p:cNvPicPr>
+            <a:picLocks noChangeAspect="1"/>
+          </p:cNvPicPr>
+          <p:nvPr/>
+        </p:nvPicPr>
+        <p:blipFill>
+          <a:blip r:embed="rId3"/>
+          <a:stretch>
+            <a:fillRect/>
+          </a:stretch>
+        </p:blipFill>
+        <p:spPr>
+          <a:xfrm>
+            <a:off x="4023360" y="2651760"/>
+            <a:ext cx="3108960" cy="1747783"/>
+          </a:xfrm>
+          <a:prstGeom prst="rect">
+            <a:avLst/>
+          </a:prstGeom>
+        </p:spPr>
+      </p:pic>
+      <p:sp>
+        <p:nvSpPr>
+          <p:cNvPr id="6" name="Rounded Rectangle 5"/>
+          <p:cNvSpPr/>
+          <p:nvPr/>
+        </p:nvSpPr>
+        <p:spPr>
+          <a:xfrm>
+            <a:off x="7680960" y="1188720"/>
+            <a:ext cx="4023360" cy="5303520"/>
+          </a:xfrm>
+          <a:prstGeom prst="roundRect">
+            <a:avLst/>
+          </a:prstGeom>
+          <a:solidFill>
+            <a:srgbClr val="0F172A"/>
+          </a:solidFill>
+          <a:ln>
+            <a:solidFill>
+              <a:srgbClr val="9333EA"/>
+            </a:solidFill>
+          </a:ln>
+        </p:spPr>
+        <p:style>
+          <a:lnRef idx="1">
+            <a:schemeClr val="accent1"/>
+          </a:lnRef>
+          <a:fillRef idx="3">
+            <a:schemeClr val="accent1"/>
+          </a:fillRef>
+          <a:effectRef idx="2">
+            <a:schemeClr val="accent1"/>
+          </a:effectRef>
+          <a:fontRef idx="minor">
+            <a:schemeClr val="lt1"/>
+          </a:fontRef>
+        </p:style>
+        <p:txBody>
+          <a:bodyPr rtlCol="0" anchor="ctr" lIns="274320" tIns="182880"/>
+          <a:lstStyle/>
+          <a:p>
+            <a:pPr algn="ctr">
+              <a:defRPr sz="1300" b="1">
+                <a:solidFill>
+                  <a:srgbClr val="FFFFFF"/>
+                </a:solidFill>
+                <a:latin typeface="Segoe UI"/>
+              </a:defRPr>
+            </a:pPr>
+            <a:r>
+              <a:t>Sala Previa &amp; Sanitarios</a:t>
+            </a:r>
+          </a:p>
+          <a:p>
+            <a:pPr>
+              <a:defRPr sz="1000">
+                <a:solidFill>
+                  <a:srgbClr val="E2E8F0"/>
+                </a:solidFill>
+                <a:latin typeface="Segoe UI"/>
+              </a:defRPr>
+            </a:pPr>
+            <a:r>
+              <a:t>• Sala Previa:</a:t>
+            </a:r>
+            <a:br/>
+            <a:r>
+              <a:t>Recepción y preparación antes del ingreso al auditorio. Cuenta con mesa de reuniones ejecutiva, sillas y sillones para coordinación y entrevistas.</a:t>
+            </a:r>
+            <a:br/>
+            <a:br/>
+            <a:r>
+              <a:t>• Baños Diferenciados:</a:t>
+            </a:r>
+            <a:br/>
+            <a:r>
+              <a:t>Sanitarios para Damas y Caballeros en ubicación central de fácil acceso desde Gabinete, Auditorio y Escalera.</a:t>
+            </a:r>
+            <a:br/>
+            <a:br/>
+            <a:r>
+              <a:t>• Conectividad:</a:t>
+            </a:r>
+            <a:br/>
+            <a:r>
+              <a:t>Punto Wi-Fi Mesh Deco n2 sobre el pasillo de acceso.</a:t>
+            </a:r>
+          </a:p>
+        </p:txBody>
+      </p:sp>
+    </p:spTree>
+  </p:cSld>
+  <p:clrMapOvr>
+    <a:masterClrMapping/>
+  </p:clrMapOvr>
+</p:sld>
+</file>
+
+<file path=ppt/slides/slide14.xml><?xml version="1.0" encoding="utf-8"?>
+<p:sld xmlns:a="http://schemas.openxmlformats.org/drawingml/2006/main" xmlns:p="http://schemas.openxmlformats.org/presentationml/2006/main" xmlns:r="http://schemas.openxmlformats.org/officeDocument/2006/relationships">
+  <p:cSld>
+    <p:spTree>
+      <p:nvGrpSpPr>
+        <p:cNvPr id="1" name=""/>
+        <p:cNvGrpSpPr/>
+        <p:nvPr/>
+      </p:nvGrpSpPr>
+      <p:grpSpPr/>
+      <p:sp>
+        <p:nvSpPr>
+          <p:cNvPr id="2" name="Rectangle 1"/>
+          <p:cNvSpPr/>
+          <p:nvPr/>
+        </p:nvSpPr>
+        <p:spPr>
+          <a:xfrm>
+            <a:off x="0" y="0"/>
+            <a:ext cx="12191695" cy="1005840"/>
+          </a:xfrm>
+          <a:prstGeom prst="rect">
+            <a:avLst/>
+          </a:prstGeom>
+          <a:solidFill>
+            <a:srgbClr val="0F172A"/>
+          </a:solidFill>
+          <a:ln w="25400">
+            <a:solidFill>
+              <a:srgbClr val="2563EB"/>
+            </a:solidFill>
+          </a:ln>
+        </p:spPr>
+        <p:style>
+          <a:lnRef idx="1">
+            <a:schemeClr val="accent1"/>
+          </a:lnRef>
+          <a:fillRef idx="3">
+            <a:schemeClr val="accent1"/>
+          </a:fillRef>
+          <a:effectRef idx="2">
+            <a:schemeClr val="accent1"/>
+          </a:effectRef>
+          <a:fontRef idx="minor">
+            <a:schemeClr val="lt1"/>
+          </a:fontRef>
+        </p:style>
+        <p:txBody>
+          <a:bodyPr rtlCol="0" anchor="ctr" wrap="square" lIns="457200" tIns="137160"/>
+          <a:lstStyle/>
+          <a:p>
+            <a:pPr algn="ctr">
+              <a:defRPr sz="2000" b="1">
+                <a:solidFill>
+                  <a:srgbClr val="FFFFFF"/>
+                </a:solidFill>
+                <a:latin typeface="Segoe UI"/>
+              </a:defRPr>
+            </a:pPr>
+            <a:r>
+              <a:t>SALA DE STREAMING &amp; SECTOR DE TÍTULOS</a:t>
+            </a:r>
+          </a:p>
+          <a:p>
+            <a:pPr>
+              <a:defRPr sz="1100">
+                <a:solidFill>
+                  <a:srgbClr val="0EA5E9"/>
+                </a:solidFill>
+                <a:latin typeface="Segoe UI"/>
+              </a:defRPr>
+            </a:pPr>
+            <a:r>
+              <a:t>Centro multimedia de transmisión institucional y área administrativa de documentación</a:t>
+            </a:r>
+          </a:p>
+        </p:txBody>
+      </p:sp>
+      <p:sp>
+        <p:nvSpPr>
+          <p:cNvPr id="3" name="Rounded Rectangle 2"/>
+          <p:cNvSpPr/>
+          <p:nvPr/>
+        </p:nvSpPr>
+        <p:spPr>
+          <a:xfrm>
+            <a:off x="457200" y="1188720"/>
+            <a:ext cx="6949440" cy="5303520"/>
+          </a:xfrm>
+          <a:prstGeom prst="roundRect">
+            <a:avLst/>
+          </a:prstGeom>
+          <a:solidFill>
+            <a:srgbClr val="FFFFFF"/>
+          </a:solidFill>
+          <a:ln>
+            <a:solidFill>
+              <a:srgbClr val="CBD5E1"/>
+            </a:solidFill>
+          </a:ln>
+        </p:spPr>
+        <p:style>
+          <a:lnRef idx="1">
+            <a:schemeClr val="accent1"/>
+          </a:lnRef>
+          <a:fillRef idx="3">
+            <a:schemeClr val="accent1"/>
+          </a:fillRef>
+          <a:effectRef idx="2">
+            <a:schemeClr val="accent1"/>
+          </a:effectRef>
+          <a:fontRef idx="minor">
+            <a:schemeClr val="lt1"/>
+          </a:fontRef>
+        </p:style>
+        <p:txBody>
+          <a:bodyPr rtlCol="0" anchor="ctr" lIns="274320" tIns="182880"/>
+          <a:lstStyle/>
+          <a:p>
+            <a:pPr algn="ctr">
+              <a:defRPr sz="1300" b="1">
+                <a:solidFill>
+                  <a:srgbClr val="0F172A"/>
+                </a:solidFill>
+                <a:latin typeface="Segoe UI"/>
+              </a:defRPr>
+            </a:pPr>
+            <a:r>
+              <a:t>Sala de Streaming / Transmisión IESNH</a:t>
+            </a:r>
+          </a:p>
+          <a:p>
+            <a:pPr>
+              <a:defRPr sz="1000">
+                <a:solidFill>
+                  <a:srgbClr val="0F172A"/>
+                </a:solidFill>
+                <a:latin typeface="Segoe UI"/>
+              </a:defRPr>
+            </a:pPr>
+            <a:r>
+              <a:t>Preparada para producción de contenidos, streaming en vivo, clases magistrales y podcasts. Mesa curvada frontal para 4 conductores con micrófonos articulados y puesto técnico con 3 PCs en red cableada.</a:t>
+            </a:r>
+          </a:p>
+        </p:txBody>
+      </p:sp>
+      <p:pic>
+        <p:nvPicPr>
+          <p:cNvPr id="4" name="Picture 3" descr="foto_streaming_mesa_conductores.jpeg"/>
+          <p:cNvPicPr>
+            <a:picLocks noChangeAspect="1"/>
+          </p:cNvPicPr>
+          <p:nvPr/>
+        </p:nvPicPr>
+        <p:blipFill>
+          <a:blip r:embed="rId2"/>
+          <a:stretch>
+            <a:fillRect/>
+          </a:stretch>
+        </p:blipFill>
+        <p:spPr>
+          <a:xfrm>
+            <a:off x="731520" y="2651760"/>
+            <a:ext cx="3108960" cy="1746516"/>
+          </a:xfrm>
+          <a:prstGeom prst="rect">
+            <a:avLst/>
+          </a:prstGeom>
+        </p:spPr>
+      </p:pic>
+      <p:pic>
+        <p:nvPicPr>
+          <p:cNvPr id="5" name="Picture 4" descr="foto_streaming_puesto_tecnico.jpeg"/>
+          <p:cNvPicPr>
+            <a:picLocks noChangeAspect="1"/>
+          </p:cNvPicPr>
+          <p:nvPr/>
+        </p:nvPicPr>
+        <p:blipFill>
+          <a:blip r:embed="rId3"/>
+          <a:stretch>
+            <a:fillRect/>
+          </a:stretch>
+        </p:blipFill>
+        <p:spPr>
+          <a:xfrm>
+            <a:off x="4023360" y="2651760"/>
+            <a:ext cx="3108960" cy="1752323"/>
+          </a:xfrm>
+          <a:prstGeom prst="rect">
+            <a:avLst/>
+          </a:prstGeom>
+        </p:spPr>
+      </p:pic>
+      <p:sp>
+        <p:nvSpPr>
+          <p:cNvPr id="6" name="Rounded Rectangle 5"/>
+          <p:cNvSpPr/>
+          <p:nvPr/>
+        </p:nvSpPr>
+        <p:spPr>
+          <a:xfrm>
+            <a:off x="7680960" y="1188720"/>
+            <a:ext cx="4023360" cy="5303520"/>
+          </a:xfrm>
+          <a:prstGeom prst="roundRect">
+            <a:avLst/>
+          </a:prstGeom>
+          <a:solidFill>
+            <a:srgbClr val="0F172A"/>
+          </a:solidFill>
+          <a:ln>
+            <a:solidFill>
+              <a:srgbClr val="10B981"/>
+            </a:solidFill>
+          </a:ln>
+        </p:spPr>
+        <p:style>
+          <a:lnRef idx="1">
+            <a:schemeClr val="accent1"/>
+          </a:lnRef>
+          <a:fillRef idx="3">
+            <a:schemeClr val="accent1"/>
+          </a:fillRef>
+          <a:effectRef idx="2">
+            <a:schemeClr val="accent1"/>
+          </a:effectRef>
+          <a:fontRef idx="minor">
+            <a:schemeClr val="lt1"/>
+          </a:fontRef>
+        </p:style>
+        <p:txBody>
+          <a:bodyPr rtlCol="0" anchor="ctr" lIns="274320" tIns="182880"/>
+          <a:lstStyle/>
+          <a:p>
+            <a:pPr algn="ctr">
+              <a:defRPr sz="1300" b="1">
+                <a:solidFill>
+                  <a:srgbClr val="FFFFFF"/>
+                </a:solidFill>
+                <a:latin typeface="Segoe UI"/>
+              </a:defRPr>
+            </a:pPr>
+            <a:r>
+              <a:t>Sector Títulos &amp; Aula Académica</a:t>
+            </a:r>
+          </a:p>
+          <a:p>
+            <a:pPr>
+              <a:defRPr sz="1000">
+                <a:solidFill>
+                  <a:srgbClr val="E2E8F0"/>
+                </a:solidFill>
+                <a:latin typeface="Segoe UI"/>
+              </a:defRPr>
+            </a:pPr>
+            <a:r>
+              <a:t>• Sector de Títulos:</a:t>
+            </a:r>
+            <a:br/>
+            <a:r>
+              <a:t>Espacio destinado a la gestión académica, organización, entrega y resguardo de títulos y certificados analíticos. Mesa de reuniones ejecutiva para 10 personas conectada a la red.</a:t>
+            </a:r>
+            <a:br/>
+            <a:br/>
+            <a:r>
+              <a:t>• Aula Académica (AuLA):</a:t>
+            </a:r>
+            <a:br/>
+            <a:r>
+              <a:t>Espacio equipado para el dictado de clases y capacitaciones teóricas con cobertura de red completa.</a:t>
+            </a:r>
+          </a:p>
+        </p:txBody>
+      </p:sp>
+      <p:pic>
+        <p:nvPicPr>
+          <p:cNvPr id="7" name="Picture 6" descr="foto_aula.jpeg"/>
+          <p:cNvPicPr>
+            <a:picLocks noChangeAspect="1"/>
+          </p:cNvPicPr>
+          <p:nvPr/>
+        </p:nvPicPr>
+        <p:blipFill>
+          <a:blip r:embed="rId4"/>
+          <a:stretch>
+            <a:fillRect/>
+          </a:stretch>
+        </p:blipFill>
+        <p:spPr>
+          <a:xfrm>
+            <a:off x="8046720" y="3474720"/>
+            <a:ext cx="3291840" cy="4389120"/>
+          </a:xfrm>
+          <a:prstGeom prst="rect">
+            <a:avLst/>
+          </a:prstGeom>
+        </p:spPr>
+      </p:pic>
+    </p:spTree>
+  </p:cSld>
+  <p:clrMapOvr>
+    <a:masterClrMapping/>
+  </p:clrMapOvr>
+</p:sld>
+</file>
+
+<file path=ppt/slides/slide15.xml><?xml version="1.0" encoding="utf-8"?>
+<p:sld xmlns:a="http://schemas.openxmlformats.org/drawingml/2006/main" xmlns:p="http://schemas.openxmlformats.org/presentationml/2006/main" xmlns:r="http://schemas.openxmlformats.org/officeDocument/2006/relationships">
+  <p:cSld>
+    <p:spTree>
+      <p:nvGrpSpPr>
+        <p:cNvPr id="1" name=""/>
+        <p:cNvGrpSpPr/>
+        <p:nvPr/>
+      </p:nvGrpSpPr>
+      <p:grpSpPr/>
+      <p:sp>
+        <p:nvSpPr>
+          <p:cNvPr id="2" name="Rectangle 1"/>
+          <p:cNvSpPr/>
+          <p:nvPr/>
+        </p:nvSpPr>
+        <p:spPr>
+          <a:xfrm>
+            <a:off x="0" y="0"/>
+            <a:ext cx="12191695" cy="1005840"/>
+          </a:xfrm>
+          <a:prstGeom prst="rect">
+            <a:avLst/>
+          </a:prstGeom>
+          <a:solidFill>
+            <a:srgbClr val="0F172A"/>
+          </a:solidFill>
+          <a:ln w="25400">
+            <a:solidFill>
+              <a:srgbClr val="2563EB"/>
+            </a:solidFill>
+          </a:ln>
+        </p:spPr>
+        <p:style>
+          <a:lnRef idx="1">
+            <a:schemeClr val="accent1"/>
+          </a:lnRef>
+          <a:fillRef idx="3">
+            <a:schemeClr val="accent1"/>
+          </a:fillRef>
+          <a:effectRef idx="2">
+            <a:schemeClr val="accent1"/>
+          </a:effectRef>
+          <a:fontRef idx="minor">
+            <a:schemeClr val="lt1"/>
+          </a:fontRef>
+        </p:style>
+        <p:txBody>
+          <a:bodyPr rtlCol="0" anchor="ctr" wrap="square" lIns="457200" tIns="137160"/>
+          <a:lstStyle/>
+          <a:p>
+            <a:pPr algn="ctr">
+              <a:defRPr sz="2000" b="1">
+                <a:solidFill>
+                  <a:srgbClr val="FFFFFF"/>
+                </a:solidFill>
+                <a:latin typeface="Segoe UI"/>
+              </a:defRPr>
+            </a:pPr>
+            <a:r>
+              <a:t>ARQUITECTURA DE TELECOMUNICACIONES  •  Planta Alta</a:t>
+            </a:r>
+          </a:p>
+          <a:p>
+            <a:pPr>
+              <a:defRPr sz="1100">
+                <a:solidFill>
+                  <a:srgbClr val="0EA5E9"/>
+                </a:solidFill>
+                <a:latin typeface="Segoe UI"/>
+              </a:defRPr>
+            </a:pPr>
+            <a:r>
+              <a:t>Topología cableada Cat6, Rack 48P Hikvision, módem Huawei y cobertura Wi-Fi Mesh Decos</a:t>
+            </a:r>
+          </a:p>
+        </p:txBody>
+      </p:sp>
+      <p:sp>
+        <p:nvSpPr>
+          <p:cNvPr id="3" name="Rounded Rectangle 2"/>
+          <p:cNvSpPr/>
+          <p:nvPr/>
+        </p:nvSpPr>
+        <p:spPr>
+          <a:xfrm>
+            <a:off x="457200" y="1188720"/>
+            <a:ext cx="11277295" cy="5303520"/>
+          </a:xfrm>
+          <a:prstGeom prst="roundRect">
+            <a:avLst/>
+          </a:prstGeom>
+          <a:solidFill>
+            <a:srgbClr val="0F172A"/>
+          </a:solidFill>
+          <a:ln>
+            <a:solidFill>
+              <a:srgbClr val="0EA5E9"/>
+            </a:solidFill>
+          </a:ln>
+        </p:spPr>
+        <p:style>
+          <a:lnRef idx="1">
+            <a:schemeClr val="accent1"/>
+          </a:lnRef>
+          <a:fillRef idx="3">
+            <a:schemeClr val="accent1"/>
+          </a:fillRef>
+          <a:effectRef idx="2">
+            <a:schemeClr val="accent1"/>
+          </a:effectRef>
+          <a:fontRef idx="minor">
+            <a:schemeClr val="lt1"/>
+          </a:fontRef>
+        </p:style>
+        <p:txBody>
+          <a:bodyPr rtlCol="0" anchor="ctr" lIns="457200" tIns="274320"/>
+          <a:lstStyle/>
+          <a:p>
+            <a:pPr algn="ctr">
+              <a:defRPr sz="1600" b="1">
+                <a:solidFill>
+                  <a:srgbClr val="FFFFFF"/>
+                </a:solidFill>
+                <a:latin typeface="Segoe UI"/>
+              </a:defRPr>
+            </a:pPr>
+            <a:r>
+              <a:t>Resumen de la Infraestructura de Conectividad (Planta Alta)</a:t>
+            </a:r>
+          </a:p>
+          <a:p>
+            <a:pPr>
+              <a:defRPr sz="1100" b="1">
+                <a:solidFill>
+                  <a:srgbClr val="0EA5E9"/>
+                </a:solidFill>
+                <a:latin typeface="Segoe UI"/>
+              </a:defRPr>
+            </a:pPr>
+            <a:r>
+              <a:t>• Centro de Estrella (Rack Mural 6U): </a:t>
+            </a:r>
+            <a:r>
+              <a:rPr b="0">
+                <a:solidFill>
+                  <a:srgbClr val="E2E8F0"/>
+                </a:solidFill>
+              </a:rPr>
+              <a:t>Ubicado en la esquina inferior izquierda del Gabinete. Aloja el Módem Huawei OptiXstar HG8145X6-10 y 2 switches Hikvision administrables de 24 puertos (48 puertos totales).</a:t>
+            </a:r>
+          </a:p>
+          <a:p>
+            <a:pPr>
+              <a:defRPr sz="1100" b="1">
+                <a:solidFill>
+                  <a:srgbClr val="0EA5E9"/>
+                </a:solidFill>
+                <a:latin typeface="Segoe UI"/>
+              </a:defRPr>
+            </a:pPr>
+            <a:r>
+              <a:t>• Tendido Cableado Estructurado (Líneas Rojas): </a:t>
+            </a:r>
+            <a:r>
+              <a:rPr b="0">
+                <a:solidFill>
+                  <a:srgbClr val="E2E8F0"/>
+                </a:solidFill>
+              </a:rPr>
+              <a:t>Canalización perimetral y bajadas directas a las 4 islas del Gabinete (31 PCs cableadas), derivación hacia Sector Títulos (mesa directiva) y derivación hacia Sala de Streaming (3 PCs técnicas).</a:t>
+            </a:r>
+          </a:p>
+          <a:p>
+            <a:pPr>
+              <a:defRPr sz="1100" b="1">
+                <a:solidFill>
+                  <a:srgbClr val="0EA5E9"/>
+                </a:solidFill>
+                <a:latin typeface="Segoe UI"/>
+              </a:defRPr>
+            </a:pPr>
+            <a:r>
+              <a:t>• Red Inalámbrica Mesh (Deco): </a:t>
+            </a:r>
+            <a:r>
+              <a:rPr b="0">
+                <a:solidFill>
+                  <a:srgbClr val="E2E8F0"/>
+                </a:solidFill>
+              </a:rPr>
+              <a:t>Tres nodos estratégicos para roaming ininterrumpido:
+   • Deco 1: En Gabinete Informático (pared norte).
+   • Deco n2: En Pasillo central frente a sanitarios y acceso a escalera.
+   • Deco n3: En Auditorio Institucional (esquina superior izquierda junto al escenario).</a:t>
+            </a:r>
+          </a:p>
+          <a:p>
+            <a:pPr>
+              <a:defRPr sz="1100" b="1">
+                <a:solidFill>
+                  <a:srgbClr val="0EA5E9"/>
+                </a:solidFill>
+                <a:latin typeface="Segoe UI"/>
+              </a:defRPr>
+            </a:pPr>
+            <a:r>
+              <a:t>• Enlace Troncal a Planta Baja: </a:t>
+            </a:r>
+            <a:r>
+              <a:rPr b="0">
+                <a:solidFill>
+                  <a:srgbClr val="E2E8F0"/>
+                </a:solidFill>
+              </a:rPr>
+              <a:t>Tirada vertical a través del núcleo de escalera conectando con el Rack Central de Planta Baja (Kiosco / Rectoría).</a:t>
+            </a:r>
+          </a:p>
+          <a:p>
+            <a:pPr>
+              <a:defRPr sz="1100" b="1">
+                <a:solidFill>
+                  <a:srgbClr val="0EA5E9"/>
+                </a:solidFill>
+                <a:latin typeface="Segoe UI"/>
+              </a:defRPr>
+            </a:pPr>
+            <a:r>
+              <a:t>• Capacidad Total: </a:t>
+            </a:r>
+            <a:r>
+              <a:rPr b="0">
+                <a:solidFill>
+                  <a:srgbClr val="E2E8F0"/>
+                </a:solidFill>
+              </a:rPr>
+              <a:t>Soporte para más de 150 dispositivos concurrentes entre red cableada y Wi-Fi.</a:t>
             </a:r>
           </a:p>
         </p:txBody>

</xml_diff>